<commit_message>
Add HueveraMarketing pptx for Canva
</commit_message>
<xml_diff>
--- a/HueveraMarketing/Extra Blanco 180 - FB 1080x1080.pptx
+++ b/HueveraMarketing/Extra Blanco 180 - FB 1080x1080.pptx
@@ -3084,7 +3084,7 @@
     <p:bg>
       <p:bgPr>
         <a:solidFill>
-          <a:srgbClr val="FFFFFF"/>
+          <a:srgbClr val="14181F"/>
         </a:solidFill>
         <a:effectLst/>
       </p:bgPr>
@@ -3098,7 +3098,7 @@
       <p:grpSpPr/>
       <p:pic>
         <p:nvPicPr>
-          <p:cNvPr id="2" name="Picture 1" descr="eb_45.png"/>
+          <p:cNvPr id="2" name="Picture 1" descr="eb_45_r8229600x3400044_center.png"/>
           <p:cNvPicPr>
             <a:picLocks noChangeAspect="1"/>
           </p:cNvPicPr>
@@ -3112,8 +3112,8 @@
         </p:blipFill>
         <p:spPr>
           <a:xfrm>
-            <a:off x="0" y="-993227"/>
-            <a:ext cx="8229600" cy="10216055"/>
+            <a:off x="0" y="0"/>
+            <a:ext cx="8229600" cy="3400044"/>
           </a:xfrm>
           <a:prstGeom prst="rect">
             <a:avLst/>
@@ -3122,20 +3122,22 @@
       </p:pic>
       <p:sp>
         <p:nvSpPr>
-          <p:cNvPr id="3" name="Rectangle 2"/>
+          <p:cNvPr id="3" name="Rounded Rectangle 2"/>
           <p:cNvSpPr/>
           <p:nvPr/>
         </p:nvSpPr>
         <p:spPr>
           <a:xfrm>
-            <a:off x="0" y="3703320"/>
-            <a:ext cx="8229600" cy="4526280"/>
+            <a:off x="777240" y="3811524"/>
+            <a:ext cx="3024378" cy="373380"/>
           </a:xfrm>
-          <a:prstGeom prst="rect">
-            <a:avLst/>
+          <a:prstGeom prst="roundRect">
+            <a:avLst>
+              <a:gd name="adj" fmla="val 50000"/>
+            </a:avLst>
           </a:prstGeom>
           <a:solidFill>
-            <a:srgbClr val="14181F"/>
+            <a:srgbClr val="F5C13F"/>
           </a:solidFill>
           <a:ln>
             <a:noFill/>
@@ -3157,52 +3159,6 @@
           </a:fontRef>
         </p:style>
         <p:txBody>
-          <a:bodyPr rtlCol="0" anchor="ctr"/>
-          <a:lstStyle/>
-          <a:p>
-            <a:pPr algn="ctr"/>
-          </a:p>
-        </p:txBody>
-      </p:sp>
-      <p:sp>
-        <p:nvSpPr>
-          <p:cNvPr id="4" name="Rounded Rectangle 3"/>
-          <p:cNvSpPr/>
-          <p:nvPr/>
-        </p:nvSpPr>
-        <p:spPr>
-          <a:xfrm>
-            <a:off x="777240" y="777240"/>
-            <a:ext cx="3024378" cy="373380"/>
-          </a:xfrm>
-          <a:prstGeom prst="roundRect">
-            <a:avLst>
-              <a:gd name="adj" fmla="val 50000"/>
-            </a:avLst>
-          </a:prstGeom>
-          <a:solidFill>
-            <a:srgbClr val="14181F"/>
-          </a:solidFill>
-          <a:ln>
-            <a:noFill/>
-          </a:ln>
-          <a:effectLst/>
-        </p:spPr>
-        <p:style>
-          <a:lnRef idx="1">
-            <a:schemeClr val="accent1"/>
-          </a:lnRef>
-          <a:fillRef idx="3">
-            <a:schemeClr val="accent1"/>
-          </a:fillRef>
-          <a:effectRef idx="2">
-            <a:schemeClr val="accent1"/>
-          </a:effectRef>
-          <a:fontRef idx="minor">
-            <a:schemeClr val="lt1"/>
-          </a:fontRef>
-        </p:style>
-        <p:txBody>
           <a:bodyPr rtlCol="0" anchor="ctr" wrap="none" lIns="128016" rIns="128016" tIns="18288" bIns="18288"/>
           <a:lstStyle/>
           <a:p>
@@ -3210,7 +3166,7 @@
             <a:r>
               <a:rPr sz="1500" b="1">
                 <a:solidFill>
-                  <a:srgbClr val="F5C13F"/>
+                  <a:srgbClr val="14181F"/>
                 </a:solidFill>
                 <a:latin typeface="Bricolage Grotesque"/>
               </a:rPr>
@@ -3221,14 +3177,14 @@
       </p:sp>
       <p:sp>
         <p:nvSpPr>
-          <p:cNvPr id="5" name="TextBox 4"/>
+          <p:cNvPr id="4" name="TextBox 3"/>
           <p:cNvSpPr txBox="1"/>
           <p:nvPr/>
         </p:nvSpPr>
         <p:spPr>
           <a:xfrm>
-            <a:off x="777240" y="4114800"/>
-            <a:ext cx="6675120" cy="2483358"/>
+            <a:off x="777240" y="4469892"/>
+            <a:ext cx="6675120" cy="1626108"/>
           </a:xfrm>
           <a:prstGeom prst="rect">
             <a:avLst/>
@@ -3247,7 +3203,7 @@
               </a:lnSpc>
             </a:pPr>
             <a:r>
-              <a:rPr sz="4600" b="1">
+              <a:rPr sz="4200" b="1">
                 <a:solidFill>
                   <a:srgbClr val="FFFFFF"/>
                 </a:solidFill>
@@ -3260,14 +3216,14 @@
       </p:sp>
       <p:sp>
         <p:nvSpPr>
-          <p:cNvPr id="6" name="TextBox 5"/>
+          <p:cNvPr id="5" name="TextBox 4"/>
           <p:cNvSpPr txBox="1"/>
           <p:nvPr/>
         </p:nvSpPr>
         <p:spPr>
           <a:xfrm>
-            <a:off x="777240" y="6726174"/>
-            <a:ext cx="6675120" cy="789939"/>
+            <a:off x="777240" y="6096000"/>
+            <a:ext cx="6675120" cy="899160"/>
           </a:xfrm>
           <a:prstGeom prst="rect">
             <a:avLst/>
@@ -3282,11 +3238,11 @@
           <a:p>
             <a:pPr algn="l">
               <a:lnSpc>
-                <a:spcPct val="105000"/>
+                <a:spcPct val="110000"/>
               </a:lnSpc>
             </a:pPr>
             <a:r>
-              <a:rPr sz="2200" b="0">
+              <a:rPr sz="2400" b="0">
                 <a:solidFill>
                   <a:srgbClr val="FFFFFF"/>
                 </a:solidFill>
@@ -3299,14 +3255,14 @@
       </p:sp>
       <p:sp>
         <p:nvSpPr>
-          <p:cNvPr id="7" name="TextBox 6"/>
+          <p:cNvPr id="6" name="TextBox 5"/>
           <p:cNvSpPr txBox="1"/>
           <p:nvPr/>
         </p:nvSpPr>
         <p:spPr>
           <a:xfrm>
-            <a:off x="777240" y="7644129"/>
-            <a:ext cx="6675120" cy="502920"/>
+            <a:off x="777240" y="7269480"/>
+            <a:ext cx="6675120" cy="548640"/>
           </a:xfrm>
           <a:prstGeom prst="rect">
             <a:avLst/>
@@ -3325,13 +3281,22 @@
               </a:lnSpc>
             </a:pPr>
             <a:r>
-              <a:rPr sz="2200" b="1">
+              <a:rPr sz="1800" b="1">
+                <a:solidFill>
+                  <a:srgbClr val="F5C13F"/>
+                </a:solidFill>
+                <a:latin typeface="Bricolage Grotesque"/>
+              </a:rPr>
+              <a:t>●  </a:t>
+            </a:r>
+            <a:r>
+              <a:rPr sz="1800" b="1">
                 <a:solidFill>
                   <a:srgbClr val="FFFFFF"/>
                 </a:solidFill>
                 <a:latin typeface="Bricolage Grotesque"/>
               </a:rPr>
-              <a:t>Pídela en huevera.cl</a:t>
+              <a:t>Huevera   @huevera.cl</a:t>
             </a:r>
           </a:p>
         </p:txBody>

</xml_diff>